<commit_message>
Progetto finale commit finale
</commit_message>
<xml_diff>
--- a/Progetto_finale/PRESENTAZIONE.pptx
+++ b/Progetto_finale/PRESENTAZIONE.pptx
@@ -13205,10 +13205,10 @@
                 <a:ea typeface="Courier New" pitchFamily="34" charset="-122"/>
                 <a:cs typeface="Courier New" pitchFamily="34" charset="-120"/>
               </a:rPr>
-              <a:t>recursive_df</a:t>
-            </a:r>
-            <a:r>
-              <a:rPr kumimoji="0" lang="en-US" sz="1300" b="1" i="0" u="none" strike="noStrike" kern="1200" cap="none" spc="0" normalizeH="0" baseline="0" noProof="0" dirty="0">
+              <a:t>recursive</a:t>
+            </a:r>
+            <a:r>
+              <a:rPr kumimoji="0" lang="en-US" sz="1300" b="1" i="0" u="none" strike="noStrike" kern="1200" cap="none" spc="0" normalizeH="0" baseline="0" noProof="0" err="1">
                 <a:ln>
                   <a:noFill/>
                 </a:ln>
@@ -13222,7 +13222,24 @@
                 <a:ea typeface="Courier New" pitchFamily="34" charset="-122"/>
                 <a:cs typeface="Courier New" pitchFamily="34" charset="-120"/>
               </a:rPr>
-              <a:t> </a:t>
+              <a:t>_</a:t>
+            </a:r>
+            <a:r>
+              <a:rPr kumimoji="0" lang="en-US" sz="1300" b="1" i="0" u="none" strike="noStrike" kern="1200" cap="none" spc="0" normalizeH="0" baseline="0" noProof="0">
+                <a:ln>
+                  <a:noFill/>
+                </a:ln>
+                <a:solidFill>
+                  <a:srgbClr val="4472C4"/>
+                </a:solidFill>
+                <a:effectLst/>
+                <a:uLnTx/>
+                <a:uFillTx/>
+                <a:latin typeface="Courier New" pitchFamily="34" charset="0"/>
+                <a:ea typeface="Courier New" pitchFamily="34" charset="-122"/>
+                <a:cs typeface="Courier New" pitchFamily="34" charset="-120"/>
+              </a:rPr>
+              <a:t>dfs </a:t>
             </a:r>
             <a:r>
               <a:rPr kumimoji="0" lang="en-US" sz="1313" b="0" i="0" u="none" strike="noStrike" kern="1200" cap="none" spc="0" normalizeH="0" baseline="0" noProof="0" dirty="0" err="1">

</xml_diff>